<commit_message>
Add workspace-mode rendering with UUID asset directories
Introduce src/workspace_loader.py so images and text can be supplied
from a per-session workspace folder instead of inline JSON, with
path-traversal safeguards, UUID4 naming rules, per-occurrence image
regions and cover-crop. Extend verify.py to cover the new checks.
</commit_message>
<xml_diff>
--- a/templates/sales_report_template.pptx
+++ b/templates/sales_report_template.pptx
@@ -8,6 +8,7 @@
     <p:sldId id="256" r:id="rId7"/>
     <p:sldId id="257" r:id="rId8"/>
     <p:sldId id="258" r:id="rId9"/>
+    <p:sldId id="259" r:id="rId10"/>
   </p:sldIdLst>
   <p:sldSz cx="12191695" cy="6858000" type="screen4x3"/>
   <p:notesSz cx="6858000" cy="9144000"/>
@@ -3282,6 +3283,61 @@
           </a:p>
         </p:txBody>
       </p:sp>
+      <p:sp>
+        <p:nvSpPr>
+          <p:cNvPr id="7" name="Rectangle 6"/>
+          <p:cNvSpPr/>
+          <p:nvPr/>
+        </p:nvSpPr>
+        <p:spPr>
+          <a:xfrm>
+            <a:off x="9966960" y="4526280"/>
+            <a:ext cx="1463040" cy="1463040"/>
+          </a:xfrm>
+          <a:prstGeom prst="rect">
+            <a:avLst/>
+          </a:prstGeom>
+          <a:solidFill>
+            <a:srgbClr val="E3E8EF"/>
+          </a:solidFill>
+          <a:ln>
+            <a:solidFill>
+              <a:srgbClr val="B8C2D1"/>
+            </a:solidFill>
+          </a:ln>
+          <a:effectLst/>
+        </p:spPr>
+        <p:style>
+          <a:lnRef idx="1">
+            <a:schemeClr val="accent1"/>
+          </a:lnRef>
+          <a:fillRef idx="3">
+            <a:schemeClr val="accent1"/>
+          </a:fillRef>
+          <a:effectRef idx="2">
+            <a:schemeClr val="accent1"/>
+          </a:effectRef>
+          <a:fontRef idx="minor">
+            <a:schemeClr val="lt1"/>
+          </a:fontRef>
+        </p:style>
+        <p:txBody>
+          <a:bodyPr rtlCol="0" anchor="ctr" wrap="square"/>
+          <a:lstStyle/>
+          <a:p>
+            <a:pPr algn="ctr"/>
+            <a:r>
+              <a:rPr sz="900">
+                <a:solidFill>
+                  <a:srgbClr val="6B7280"/>
+                </a:solidFill>
+                <a:latin typeface="Calibri"/>
+              </a:rPr>
+              <a:t>{{image:product_image}}</a:t>
+            </a:r>
+          </a:p>
+        </p:txBody>
+      </p:sp>
     </p:spTree>
   </p:cSld>
   <p:clrMapOvr>
@@ -3389,7 +3445,42 @@
       </p:sp>
       <p:sp>
         <p:nvSpPr>
-          <p:cNvPr id="4" name="Rounded Rectangle 3"/>
+          <p:cNvPr id="4" name="TextBox 3"/>
+          <p:cNvSpPr txBox="1"/>
+          <p:nvPr/>
+        </p:nvSpPr>
+        <p:spPr>
+          <a:xfrm>
+            <a:off x="822960" y="1325880"/>
+            <a:ext cx="10515600" cy="411480"/>
+          </a:xfrm>
+          <a:prstGeom prst="rect">
+            <a:avLst/>
+          </a:prstGeom>
+          <a:noFill/>
+        </p:spPr>
+        <p:txBody>
+          <a:bodyPr wrap="square">
+            <a:spAutoFit/>
+          </a:bodyPr>
+          <a:lstStyle/>
+          <a:p>
+            <a:pPr algn="l"/>
+            <a:r>
+              <a:rPr sz="1300" b="0">
+                <a:solidFill>
+                  <a:srgbClr val="6B7280"/>
+                </a:solidFill>
+                <a:latin typeface="Calibri"/>
+              </a:rPr>
+              <a:t>Report: {{text:title}}</a:t>
+            </a:r>
+          </a:p>
+        </p:txBody>
+      </p:sp>
+      <p:sp>
+        <p:nvSpPr>
+          <p:cNvPr id="5" name="Rounded Rectangle 4"/>
           <p:cNvSpPr/>
           <p:nvPr/>
         </p:nvSpPr>
@@ -3433,7 +3524,7 @@
       </p:sp>
       <p:sp>
         <p:nvSpPr>
-          <p:cNvPr id="5" name="Rectangle 4"/>
+          <p:cNvPr id="6" name="Rectangle 5"/>
           <p:cNvSpPr/>
           <p:nvPr/>
         </p:nvSpPr>
@@ -3477,7 +3568,7 @@
       </p:sp>
       <p:sp>
         <p:nvSpPr>
-          <p:cNvPr id="6" name="TextBox 5"/>
+          <p:cNvPr id="7" name="TextBox 6"/>
           <p:cNvSpPr txBox="1"/>
           <p:nvPr/>
         </p:nvSpPr>
@@ -3512,7 +3603,7 @@
       </p:sp>
       <p:sp>
         <p:nvSpPr>
-          <p:cNvPr id="7" name="TextBox 6"/>
+          <p:cNvPr id="8" name="TextBox 7"/>
           <p:cNvSpPr txBox="1"/>
           <p:nvPr/>
         </p:nvSpPr>
@@ -3547,7 +3638,7 @@
       </p:sp>
       <p:sp>
         <p:nvSpPr>
-          <p:cNvPr id="8" name="Rounded Rectangle 7"/>
+          <p:cNvPr id="9" name="Rounded Rectangle 8"/>
           <p:cNvSpPr/>
           <p:nvPr/>
         </p:nvSpPr>
@@ -3591,7 +3682,7 @@
       </p:sp>
       <p:sp>
         <p:nvSpPr>
-          <p:cNvPr id="9" name="Rectangle 8"/>
+          <p:cNvPr id="10" name="Rectangle 9"/>
           <p:cNvSpPr/>
           <p:nvPr/>
         </p:nvSpPr>
@@ -3635,7 +3726,7 @@
       </p:sp>
       <p:sp>
         <p:nvSpPr>
-          <p:cNvPr id="10" name="TextBox 9"/>
+          <p:cNvPr id="11" name="TextBox 10"/>
           <p:cNvSpPr txBox="1"/>
           <p:nvPr/>
         </p:nvSpPr>
@@ -3670,7 +3761,7 @@
       </p:sp>
       <p:sp>
         <p:nvSpPr>
-          <p:cNvPr id="11" name="TextBox 10"/>
+          <p:cNvPr id="12" name="TextBox 11"/>
           <p:cNvSpPr txBox="1"/>
           <p:nvPr/>
         </p:nvSpPr>
@@ -3705,7 +3796,7 @@
       </p:sp>
       <p:sp>
         <p:nvSpPr>
-          <p:cNvPr id="12" name="Rounded Rectangle 11"/>
+          <p:cNvPr id="13" name="Rounded Rectangle 12"/>
           <p:cNvSpPr/>
           <p:nvPr/>
         </p:nvSpPr>
@@ -3749,7 +3840,7 @@
       </p:sp>
       <p:sp>
         <p:nvSpPr>
-          <p:cNvPr id="13" name="Rectangle 12"/>
+          <p:cNvPr id="14" name="Rectangle 13"/>
           <p:cNvSpPr/>
           <p:nvPr/>
         </p:nvSpPr>
@@ -3793,7 +3884,7 @@
       </p:sp>
       <p:sp>
         <p:nvSpPr>
-          <p:cNvPr id="14" name="TextBox 13"/>
+          <p:cNvPr id="15" name="TextBox 14"/>
           <p:cNvSpPr txBox="1"/>
           <p:nvPr/>
         </p:nvSpPr>
@@ -3828,7 +3919,7 @@
       </p:sp>
       <p:sp>
         <p:nvSpPr>
-          <p:cNvPr id="15" name="TextBox 14"/>
+          <p:cNvPr id="16" name="TextBox 15"/>
           <p:cNvSpPr txBox="1"/>
           <p:nvPr/>
         </p:nvSpPr>
@@ -3863,7 +3954,7 @@
       </p:sp>
       <p:sp>
         <p:nvSpPr>
-          <p:cNvPr id="16" name="Rounded Rectangle 15"/>
+          <p:cNvPr id="17" name="Rounded Rectangle 16"/>
           <p:cNvSpPr/>
           <p:nvPr/>
         </p:nvSpPr>
@@ -3907,7 +3998,7 @@
       </p:sp>
       <p:sp>
         <p:nvSpPr>
-          <p:cNvPr id="17" name="Rectangle 16"/>
+          <p:cNvPr id="18" name="Rectangle 17"/>
           <p:cNvSpPr/>
           <p:nvPr/>
         </p:nvSpPr>
@@ -3951,7 +4042,7 @@
       </p:sp>
       <p:sp>
         <p:nvSpPr>
-          <p:cNvPr id="18" name="TextBox 17"/>
+          <p:cNvPr id="19" name="TextBox 18"/>
           <p:cNvSpPr txBox="1"/>
           <p:nvPr/>
         </p:nvSpPr>
@@ -3986,7 +4077,7 @@
       </p:sp>
       <p:sp>
         <p:nvSpPr>
-          <p:cNvPr id="19" name="TextBox 18"/>
+          <p:cNvPr id="20" name="TextBox 19"/>
           <p:cNvSpPr txBox="1"/>
           <p:nvPr/>
         </p:nvSpPr>
@@ -4021,7 +4112,7 @@
       </p:sp>
       <p:sp>
         <p:nvSpPr>
-          <p:cNvPr id="20" name="TextBox 19"/>
+          <p:cNvPr id="21" name="TextBox 20"/>
           <p:cNvSpPr txBox="1"/>
           <p:nvPr/>
         </p:nvSpPr>
@@ -4374,6 +4465,366 @@
                 <a:latin typeface="Calibri"/>
               </a:rPr>
               <a:t>{{image:product_image}}</a:t>
+            </a:r>
+          </a:p>
+        </p:txBody>
+      </p:sp>
+      <p:sp>
+        <p:nvSpPr>
+          <p:cNvPr id="9" name="TextBox 8"/>
+          <p:cNvSpPr txBox="1"/>
+          <p:nvPr/>
+        </p:nvSpPr>
+        <p:spPr>
+          <a:xfrm>
+            <a:off x="822960" y="6355080"/>
+            <a:ext cx="10515600" cy="365760"/>
+          </a:xfrm>
+          <a:prstGeom prst="rect">
+            <a:avLst/>
+          </a:prstGeom>
+          <a:noFill/>
+        </p:spPr>
+        <p:txBody>
+          <a:bodyPr wrap="square">
+            <a:spAutoFit/>
+          </a:bodyPr>
+          <a:lstStyle/>
+          <a:p>
+            <a:pPr algn="l"/>
+            <a:r>
+              <a:rPr sz="1100" b="0">
+                <a:solidFill>
+                  <a:srgbClr val="6B7280"/>
+                </a:solidFill>
+                <a:latin typeface="Calibri"/>
+              </a:rPr>
+              <a:t>{{text:title}}</a:t>
+            </a:r>
+          </a:p>
+        </p:txBody>
+      </p:sp>
+    </p:spTree>
+  </p:cSld>
+  <p:clrMapOvr>
+    <a:masterClrMapping/>
+  </p:clrMapOvr>
+</p:sld>
+</file>
+
+<file path=ppt/slides/slide4.xml><?xml version="1.0" encoding="utf-8"?>
+<p:sld xmlns:a="http://schemas.openxmlformats.org/drawingml/2006/main" xmlns:p="http://schemas.openxmlformats.org/presentationml/2006/main" xmlns:r="http://schemas.openxmlformats.org/officeDocument/2006/relationships">
+  <p:cSld>
+    <p:bg>
+      <p:bgPr>
+        <a:solidFill>
+          <a:srgbClr val="FFFFFF"/>
+        </a:solidFill>
+        <a:effectLst/>
+      </p:bgPr>
+    </p:bg>
+    <p:spTree>
+      <p:nvGrpSpPr>
+        <p:cNvPr id="1" name=""/>
+        <p:cNvGrpSpPr/>
+        <p:nvPr/>
+      </p:nvGrpSpPr>
+      <p:grpSpPr/>
+      <p:sp>
+        <p:nvSpPr>
+          <p:cNvPr id="2" name="TextBox 1"/>
+          <p:cNvSpPr txBox="1"/>
+          <p:nvPr/>
+        </p:nvSpPr>
+        <p:spPr>
+          <a:xfrm>
+            <a:off x="822960" y="502920"/>
+            <a:ext cx="10515600" cy="731520"/>
+          </a:xfrm>
+          <a:prstGeom prst="rect">
+            <a:avLst/>
+          </a:prstGeom>
+          <a:noFill/>
+        </p:spPr>
+        <p:txBody>
+          <a:bodyPr wrap="square">
+            <a:spAutoFit/>
+          </a:bodyPr>
+          <a:lstStyle/>
+          <a:p>
+            <a:pPr algn="l"/>
+            <a:r>
+              <a:rPr sz="2800" b="1">
+                <a:solidFill>
+                  <a:srgbClr val="1F3A5F"/>
+                </a:solidFill>
+                <a:latin typeface="Calibri"/>
+              </a:rPr>
+              <a:t>Workspace Asset Test</a:t>
+            </a:r>
+          </a:p>
+        </p:txBody>
+      </p:sp>
+      <p:sp>
+        <p:nvSpPr>
+          <p:cNvPr id="3" name="Rectangle 2"/>
+          <p:cNvSpPr/>
+          <p:nvPr/>
+        </p:nvSpPr>
+        <p:spPr>
+          <a:xfrm>
+            <a:off x="868680" y="1143000"/>
+            <a:ext cx="1097280" cy="45720"/>
+          </a:xfrm>
+          <a:prstGeom prst="rect">
+            <a:avLst/>
+          </a:prstGeom>
+          <a:solidFill>
+            <a:srgbClr val="F29938"/>
+          </a:solidFill>
+          <a:ln>
+            <a:noFill/>
+          </a:ln>
+          <a:effectLst/>
+        </p:spPr>
+        <p:style>
+          <a:lnRef idx="1">
+            <a:schemeClr val="accent1"/>
+          </a:lnRef>
+          <a:fillRef idx="3">
+            <a:schemeClr val="accent1"/>
+          </a:fillRef>
+          <a:effectRef idx="2">
+            <a:schemeClr val="accent1"/>
+          </a:effectRef>
+          <a:fontRef idx="minor">
+            <a:schemeClr val="lt1"/>
+          </a:fontRef>
+        </p:style>
+        <p:txBody>
+          <a:bodyPr rtlCol="0" anchor="ctr"/>
+          <a:lstStyle/>
+          <a:p>
+            <a:pPr algn="ctr"/>
+          </a:p>
+        </p:txBody>
+      </p:sp>
+      <p:sp>
+        <p:nvSpPr>
+          <p:cNvPr id="4" name="Rectangle 3"/>
+          <p:cNvSpPr/>
+          <p:nvPr/>
+        </p:nvSpPr>
+        <p:spPr>
+          <a:xfrm>
+            <a:off x="822960" y="1737360"/>
+            <a:ext cx="2377440" cy="2377440"/>
+          </a:xfrm>
+          <a:prstGeom prst="rect">
+            <a:avLst/>
+          </a:prstGeom>
+          <a:solidFill>
+            <a:srgbClr val="E3E8EF"/>
+          </a:solidFill>
+          <a:ln>
+            <a:solidFill>
+              <a:srgbClr val="B8C2D1"/>
+            </a:solidFill>
+          </a:ln>
+          <a:effectLst/>
+        </p:spPr>
+        <p:style>
+          <a:lnRef idx="1">
+            <a:schemeClr val="accent1"/>
+          </a:lnRef>
+          <a:fillRef idx="3">
+            <a:schemeClr val="accent1"/>
+          </a:fillRef>
+          <a:effectRef idx="2">
+            <a:schemeClr val="accent1"/>
+          </a:effectRef>
+          <a:fontRef idx="minor">
+            <a:schemeClr val="lt1"/>
+          </a:fontRef>
+        </p:style>
+        <p:txBody>
+          <a:bodyPr rtlCol="0" anchor="ctr" wrap="square"/>
+          <a:lstStyle/>
+          <a:p>
+            <a:pPr algn="ctr"/>
+            <a:r>
+              <a:rPr sz="1100">
+                <a:solidFill>
+                  <a:srgbClr val="6B7280"/>
+                </a:solidFill>
+                <a:latin typeface="Calibri"/>
+              </a:rPr>
+              <a:t>{{image:product}}</a:t>
+            </a:r>
+          </a:p>
+        </p:txBody>
+      </p:sp>
+      <p:sp>
+        <p:nvSpPr>
+          <p:cNvPr id="5" name="Rectangle 4"/>
+          <p:cNvSpPr/>
+          <p:nvPr/>
+        </p:nvSpPr>
+        <p:spPr>
+          <a:xfrm>
+            <a:off x="3566160" y="1737360"/>
+            <a:ext cx="3291840" cy="1097280"/>
+          </a:xfrm>
+          <a:prstGeom prst="rect">
+            <a:avLst/>
+          </a:prstGeom>
+          <a:solidFill>
+            <a:srgbClr val="E3E8EF"/>
+          </a:solidFill>
+          <a:ln>
+            <a:solidFill>
+              <a:srgbClr val="B8C2D1"/>
+            </a:solidFill>
+          </a:ln>
+          <a:effectLst/>
+        </p:spPr>
+        <p:style>
+          <a:lnRef idx="1">
+            <a:schemeClr val="accent1"/>
+          </a:lnRef>
+          <a:fillRef idx="3">
+            <a:schemeClr val="accent1"/>
+          </a:fillRef>
+          <a:effectRef idx="2">
+            <a:schemeClr val="accent1"/>
+          </a:effectRef>
+          <a:fontRef idx="minor">
+            <a:schemeClr val="lt1"/>
+          </a:fontRef>
+        </p:style>
+        <p:txBody>
+          <a:bodyPr rtlCol="0" anchor="ctr" wrap="square"/>
+          <a:lstStyle/>
+          <a:p>
+            <a:pPr algn="ctr"/>
+            <a:r>
+              <a:rPr sz="1100">
+                <a:solidFill>
+                  <a:srgbClr val="6B7280"/>
+                </a:solidFill>
+                <a:latin typeface="Calibri"/>
+              </a:rPr>
+              <a:t>{{image:logo}}</a:t>
+            </a:r>
+          </a:p>
+        </p:txBody>
+      </p:sp>
+      <p:sp>
+        <p:nvSpPr>
+          <p:cNvPr id="6" name="Rectangle 5"/>
+          <p:cNvSpPr/>
+          <p:nvPr/>
+        </p:nvSpPr>
+        <p:spPr>
+          <a:xfrm>
+            <a:off x="7223760" y="1737360"/>
+            <a:ext cx="1097280" cy="3108960"/>
+          </a:xfrm>
+          <a:prstGeom prst="rect">
+            <a:avLst/>
+          </a:prstGeom>
+          <a:solidFill>
+            <a:srgbClr val="E3E8EF"/>
+          </a:solidFill>
+          <a:ln>
+            <a:solidFill>
+              <a:srgbClr val="B8C2D1"/>
+            </a:solidFill>
+          </a:ln>
+          <a:effectLst/>
+        </p:spPr>
+        <p:style>
+          <a:lnRef idx="1">
+            <a:schemeClr val="accent1"/>
+          </a:lnRef>
+          <a:fillRef idx="3">
+            <a:schemeClr val="accent1"/>
+          </a:fillRef>
+          <a:effectRef idx="2">
+            <a:schemeClr val="accent1"/>
+          </a:effectRef>
+          <a:fontRef idx="minor">
+            <a:schemeClr val="lt1"/>
+          </a:fontRef>
+        </p:style>
+        <p:txBody>
+          <a:bodyPr rtlCol="0" anchor="ctr" wrap="square"/>
+          <a:lstStyle/>
+          <a:p>
+            <a:pPr algn="ctr"/>
+            <a:r>
+              <a:rPr sz="900">
+                <a:solidFill>
+                  <a:srgbClr val="6B7280"/>
+                </a:solidFill>
+                <a:latin typeface="Calibri"/>
+              </a:rPr>
+              <a:t>{{image:product}}</a:t>
+            </a:r>
+          </a:p>
+        </p:txBody>
+      </p:sp>
+      <p:sp>
+        <p:nvSpPr>
+          <p:cNvPr id="7" name="Rectangle 6"/>
+          <p:cNvSpPr/>
+          <p:nvPr/>
+        </p:nvSpPr>
+        <p:spPr>
+          <a:xfrm>
+            <a:off x="8778240" y="1737360"/>
+            <a:ext cx="2011680" cy="2011680"/>
+          </a:xfrm>
+          <a:prstGeom prst="rect">
+            <a:avLst/>
+          </a:prstGeom>
+          <a:solidFill>
+            <a:srgbClr val="E3E8EF"/>
+          </a:solidFill>
+          <a:ln>
+            <a:solidFill>
+              <a:srgbClr val="B8C2D1"/>
+            </a:solidFill>
+          </a:ln>
+          <a:effectLst/>
+        </p:spPr>
+        <p:style>
+          <a:lnRef idx="1">
+            <a:schemeClr val="accent1"/>
+          </a:lnRef>
+          <a:fillRef idx="3">
+            <a:schemeClr val="accent1"/>
+          </a:fillRef>
+          <a:effectRef idx="2">
+            <a:schemeClr val="accent1"/>
+          </a:effectRef>
+          <a:fontRef idx="minor">
+            <a:schemeClr val="lt1"/>
+          </a:fontRef>
+        </p:style>
+        <p:txBody>
+          <a:bodyPr rtlCol="0" anchor="ctr" wrap="square"/>
+          <a:lstStyle/>
+          <a:p>
+            <a:pPr algn="ctr"/>
+            <a:r>
+              <a:rPr sz="1100">
+                <a:solidFill>
+                  <a:srgbClr val="6B7280"/>
+                </a:solidFill>
+                <a:latin typeface="Calibri"/>
+              </a:rPr>
+              <a:t>{{image:missing_image}}</a:t>
             </a:r>
           </a:p>
         </p:txBody>

</xml_diff>